<commit_message>
stage7: audit benchmark results, explain Redis vs RabbitMQ gap
Add bench/diagnose.py (raw Redis ceiling, publish path, publisher confirms,
Redis command counts per task) and an audit section in docs/experiment.md:
the matrix data is sound (135/135 runs with expected workers, 2% repeat spread),
but the "RabbitMQ is faster than Redis" reading was over-generalized — AMQP
publish is unconfirmed by default and the celery-redis config concentrated
broker + Flower events + result backend on one single-threaded Redis.

Co-Authored-By: Claude Opus 5 <noreply@anthropic.com>
Claude-Session: https://claude.ai/code/session_01NLQFAMDpjH1nm51iza3RDq
</commit_message>
<xml_diff>
--- a/slides/project.pptx
+++ b/slides/project.pptx
@@ -7657,7 +7657,7 @@
           <p:nvPr/>
         </p:nvGraphicFramePr>
         <p:xfrm>
-          <a:off x="566928" y="1882384"/>
+          <a:off x="566928" y="1860804"/>
           <a:ext cx="11057836" cy="1995220"/>
         </p:xfrm>
         <a:graphic>
@@ -8161,8 +8161,8 @@
         </p:nvSpPr>
         <p:spPr>
           <a:xfrm>
-            <a:off x="566928" y="4151924"/>
-            <a:ext cx="11057839" cy="2012411"/>
+            <a:off x="566928" y="4130344"/>
+            <a:ext cx="11057839" cy="2055571"/>
           </a:xfrm>
           <a:prstGeom prst="rect">
             <a:avLst/>
@@ -8186,7 +8186,7 @@
               <a:buChar char="■"/>
             </a:pPr>
             <a:r>
-              <a:rPr sz="1728" b="0">
+              <a:rPr sz="1439" b="0">
                 <a:solidFill>
                   <a:srgbClr val="1B2738"/>
                 </a:solidFill>
@@ -8195,7 +8195,7 @@
               <a:t>Накладные расходы очереди — </a:t>
             </a:r>
             <a:r>
-              <a:rPr sz="1728" b="1">
+              <a:rPr sz="1439" b="1">
                 <a:solidFill>
                   <a:srgbClr val="1B2738"/>
                 </a:solidFill>
@@ -8204,7 +8204,7 @@
               <a:t>≈3 мс</a:t>
             </a:r>
             <a:r>
-              <a:rPr sz="1728" b="0">
+              <a:rPr sz="1439" b="0">
                 <a:solidFill>
                   <a:srgbClr val="1B2738"/>
                 </a:solidFill>
@@ -8225,7 +8225,7 @@
               <a:buChar char="■"/>
             </a:pPr>
             <a:r>
-              <a:rPr sz="1728" b="1">
+              <a:rPr sz="1439" b="1">
                 <a:solidFill>
                   <a:srgbClr val="1B2738"/>
                 </a:solidFill>
@@ -8234,7 +8234,7 @@
               <a:t>От ≈50 мс полезной работы фреймворк и брокер не влияют</a:t>
             </a:r>
             <a:r>
-              <a:rPr sz="1728" b="0">
+              <a:rPr sz="1439" b="0">
                 <a:solidFill>
                   <a:srgbClr val="1B2738"/>
                 </a:solidFill>
@@ -8255,7 +8255,7 @@
               <a:buChar char="■"/>
             </a:pPr>
             <a:r>
-              <a:rPr sz="1728" b="0">
+              <a:rPr sz="1439" b="0">
                 <a:solidFill>
                   <a:srgbClr val="1B2738"/>
                 </a:solidFill>
@@ -8264,7 +8264,7 @@
               <a:t>Масштабирование воркерами — </a:t>
             </a:r>
             <a:r>
-              <a:rPr sz="1728" b="1">
+              <a:rPr sz="1439" b="1">
                 <a:solidFill>
                   <a:srgbClr val="1B2738"/>
                 </a:solidFill>
@@ -8273,7 +8273,7 @@
               <a:t>×3,4–4,1</a:t>
             </a:r>
             <a:r>
-              <a:rPr sz="1728" b="0">
+              <a:rPr sz="1439" b="0">
                 <a:solidFill>
                   <a:srgbClr val="1B2738"/>
                 </a:solidFill>
@@ -8282,7 +8282,7 @@
               <a:t> при четырёх воркерах; </a:t>
             </a:r>
             <a:r>
-              <a:rPr sz="1628" b="0">
+              <a:rPr sz="1339" b="0">
                 <a:solidFill>
                   <a:srgbClr val="E8590C"/>
                 </a:solidFill>
@@ -8291,13 +8291,79 @@
               <a:t>fork</a:t>
             </a:r>
             <a:r>
-              <a:rPr sz="1728" b="0">
+              <a:rPr sz="1439" b="0">
                 <a:solidFill>
                   <a:srgbClr val="1B2738"/>
                 </a:solidFill>
                 <a:latin typeface="Segoe UI"/>
               </a:rPr>
               <a:t> в RQ стоит порядок величины на микрозадачах.</a:t>
+            </a:r>
+          </a:p>
+          <a:p>
+            <a:pPr marL="237744" indent="-219456">
+              <a:spcAft>
+                <a:spcPts val="672"/>
+              </a:spcAft>
+              <a:buClr>
+                <a:srgbClr val="2F6FED"/>
+              </a:buClr>
+              <a:buFont typeface="Arial"/>
+              <a:buChar char="■"/>
+            </a:pPr>
+            <a:r>
+              <a:rPr sz="1439" b="1">
+                <a:solidFill>
+                  <a:srgbClr val="1B2738"/>
+                </a:solidFill>
+                <a:latin typeface="Segoe UI"/>
+              </a:rPr>
+              <a:t>Проверил контринтуитивный результат</a:t>
+            </a:r>
+            <a:r>
+              <a:rPr sz="1439" b="0">
+                <a:solidFill>
+                  <a:srgbClr val="1B2738"/>
+                </a:solidFill>
+                <a:latin typeface="Segoe UI"/>
+              </a:rPr>
+              <a:t> (RabbitMQ быстрее Redis): это не про брокеры — AMQP не подтверждает публикацию, а в конфигурации с Redis один сервер обслуживал брокер, события и результаты (26 команд на задачу против 13). С </a:t>
+            </a:r>
+            <a:r>
+              <a:rPr sz="1339" b="0">
+                <a:solidFill>
+                  <a:srgbClr val="E8590C"/>
+                </a:solidFill>
+                <a:latin typeface="Consolas"/>
+              </a:rPr>
+              <a:t>confirm_publish=True</a:t>
+            </a:r>
+            <a:r>
+              <a:rPr sz="1439" b="0">
+                <a:solidFill>
+                  <a:srgbClr val="1B2738"/>
+                </a:solidFill>
+                <a:latin typeface="Segoe UI"/>
+              </a:rPr>
+              <a:t> RabbitMQ в 8 раз медленнее Redis. Разбор — </a:t>
+            </a:r>
+            <a:r>
+              <a:rPr sz="1339" b="0">
+                <a:solidFill>
+                  <a:srgbClr val="E8590C"/>
+                </a:solidFill>
+                <a:latin typeface="Consolas"/>
+              </a:rPr>
+              <a:t>docs/experiment.md</a:t>
+            </a:r>
+            <a:r>
+              <a:rPr sz="1439" b="0">
+                <a:solidFill>
+                  <a:srgbClr val="1B2738"/>
+                </a:solidFill>
+                <a:latin typeface="Segoe UI"/>
+              </a:rPr>
+              <a:t>, «Аудит».</a:t>
             </a:r>
           </a:p>
         </p:txBody>

</xml_diff>

<commit_message>
slides: drop repository links from both decks
Co-Authored-By: Claude Opus 5 <noreply@anthropic.com>
Claude-Session: https://claude.ai/code/session_01NLQFAMDpjH1nm51iza3RDq
</commit_message>
<xml_diff>
--- a/slides/project.pptx
+++ b/slides/project.pptx
@@ -4221,31 +4221,6 @@
                 <a:latin typeface="Segoe UI"/>
               </a:rPr>
               <a:t>Кычкин Кирилл</a:t>
-            </a:r>
-          </a:p>
-          <a:p>
-            <a:pPr>
-              <a:spcAft>
-                <a:spcPts val="1200"/>
-              </a:spcAft>
-            </a:pPr>
-            <a:r>
-              <a:rPr sz="1500">
-                <a:solidFill>
-                  <a:srgbClr val="5B6B7C"/>
-                </a:solidFill>
-                <a:latin typeface="Segoe UI"/>
-              </a:rPr>
-              <a:t>Репозиторий:  </a:t>
-            </a:r>
-            <a:r>
-              <a:rPr sz="1700" b="0">
-                <a:solidFill>
-                  <a:srgbClr val="1B2738"/>
-                </a:solidFill>
-                <a:latin typeface="Consolas"/>
-              </a:rPr>
-              <a:t>github.com/kirillkychkin/report-queue</a:t>
             </a:r>
           </a:p>
           <a:p>
@@ -9501,7 +9476,7 @@
                 </a:solidFill>
                 <a:latin typeface="Segoe UI"/>
               </a:rPr>
-              <a:t> — 20×; Redis против RabbitMQ на реальных задачах — 0 %.</a:t>
+              <a:t> — 23×; Redis против RabbitMQ на реальных задачах — 0 %, а первую версию эксперимента пришлось переснять.</a:t>
             </a:r>
           </a:p>
           <a:p>
@@ -9655,7 +9630,7 @@
                 </a:solidFill>
                 <a:latin typeface="Segoe UI"/>
               </a:rPr>
-              <a:t>Репозиторий: </a:t>
+              <a:t>Проект собирается и запускается одной командой; все решения задокументированы в </a:t>
             </a:r>
             <a:r>
               <a:rPr sz="1500" b="0">
@@ -9664,7 +9639,7 @@
                 </a:solidFill>
                 <a:latin typeface="Consolas"/>
               </a:rPr>
-              <a:t>github.com/kirillkychkin/report-queue</a:t>
+              <a:t>docs/architecture.md</a:t>
             </a:r>
             <a:r>
               <a:rPr sz="1600" b="0">
@@ -9673,43 +9648,7 @@
                 </a:solidFill>
                 <a:latin typeface="Segoe UI"/>
               </a:rPr>
-              <a:t> — код, </a:t>
-            </a:r>
-            <a:r>
-              <a:rPr sz="1500" b="0">
-                <a:solidFill>
-                  <a:srgbClr val="E8590C"/>
-                </a:solidFill>
-                <a:latin typeface="Consolas"/>
-              </a:rPr>
-              <a:t>docs/</a:t>
-            </a:r>
-            <a:r>
-              <a:rPr sz="1600" b="0">
-                <a:solidFill>
-                  <a:srgbClr val="1B2738"/>
-                </a:solidFill>
-                <a:latin typeface="Segoe UI"/>
-              </a:rPr>
-              <a:t>, </a:t>
-            </a:r>
-            <a:r>
-              <a:rPr sz="1500" b="0">
-                <a:solidFill>
-                  <a:srgbClr val="E8590C"/>
-                </a:solidFill>
-                <a:latin typeface="Consolas"/>
-              </a:rPr>
-              <a:t>bench/results/</a:t>
-            </a:r>
-            <a:r>
-              <a:rPr sz="1600" b="0">
-                <a:solidFill>
-                  <a:srgbClr val="1B2738"/>
-                </a:solidFill>
-                <a:latin typeface="Segoe UI"/>
-              </a:rPr>
-              <a:t> (135 прогонов) и обе презентации.</a:t>
+              <a:t> по шаблону «решение / почему / альтернативы / где не работает».</a:t>
             </a:r>
           </a:p>
         </p:txBody>

</xml_diff>